<commit_message>
Rebuild App as Code PPT with professional narrative content
</commit_message>
<xml_diff>
--- a/app-as-code-project-summary.pptx
+++ b/app-as-code-project-summary.pptx
@@ -3103,7 +3103,7 @@
             <a:avLst/>
           </a:prstGeom>
           <a:solidFill>
-            <a:srgbClr val="E8F0FA"/>
+            <a:srgbClr val="F2F5FA"/>
           </a:solidFill>
           <a:ln>
             <a:noFill/>
@@ -3140,13 +3140,13 @@
         <p:spPr>
           <a:xfrm>
             <a:off x="0" y="0"/>
-            <a:ext cx="12188952" cy="914400"/>
+            <a:ext cx="12188952" cy="896112"/>
           </a:xfrm>
           <a:prstGeom prst="rect">
             <a:avLst/>
           </a:prstGeom>
           <a:solidFill>
-            <a:srgbClr val="0D1B3E"/>
+            <a:srgbClr val="0C1C43"/>
           </a:solidFill>
           <a:ln>
             <a:noFill/>
@@ -3182,14 +3182,14 @@
         </p:nvSpPr>
         <p:spPr>
           <a:xfrm>
-            <a:off x="0" y="914400"/>
-            <a:ext cx="12188952" cy="54864"/>
+            <a:off x="0" y="896112"/>
+            <a:ext cx="12188952" cy="41148"/>
           </a:xfrm>
           <a:prstGeom prst="rect">
             <a:avLst/>
           </a:prstGeom>
           <a:solidFill>
-            <a:srgbClr val="F0A500"/>
+            <a:srgbClr val="E8A000"/>
           </a:solidFill>
           <a:ln>
             <a:noFill/>
@@ -3225,14 +3225,14 @@
         </p:nvSpPr>
         <p:spPr>
           <a:xfrm>
-            <a:off x="164592" y="91440"/>
-            <a:ext cx="54864" cy="731520"/>
+            <a:off x="182880" y="109728"/>
+            <a:ext cx="50292" cy="676656"/>
           </a:xfrm>
           <a:prstGeom prst="rect">
             <a:avLst/>
           </a:prstGeom>
           <a:solidFill>
-            <a:srgbClr val="F0A500"/>
+            <a:srgbClr val="E8A000"/>
           </a:solidFill>
           <a:ln>
             <a:noFill/>
@@ -3268,8 +3268,8 @@
         </p:nvSpPr>
         <p:spPr>
           <a:xfrm>
-            <a:off x="274320" y="73152"/>
-            <a:ext cx="5029200" cy="457200"/>
+            <a:off x="301752" y="82296"/>
+            <a:ext cx="6400800" cy="420624"/>
           </a:xfrm>
           <a:prstGeom prst="rect">
             <a:avLst/>
@@ -3289,7 +3289,7 @@
                   <a:srgbClr val="FFFFFF"/>
                 </a:solidFill>
               </a:rPr>
-              <a:t>APP AS CODE</a:t>
+              <a:t>App as Code — CI/CD Platform</a:t>
             </a:r>
           </a:p>
         </p:txBody>
@@ -3302,8 +3302,8 @@
         </p:nvSpPr>
         <p:spPr>
           <a:xfrm>
-            <a:off x="274320" y="484632"/>
-            <a:ext cx="5029200" cy="347472"/>
+            <a:off x="301752" y="493776"/>
+            <a:ext cx="6400800" cy="320040"/>
           </a:xfrm>
           <a:prstGeom prst="rect">
             <a:avLst/>
@@ -3318,12 +3318,12 @@
           <a:p>
             <a:pPr algn="l"/>
             <a:r>
-              <a:rPr sz="1100" b="0" i="0">
+              <a:rPr sz="1050" b="0" i="1">
                 <a:solidFill>
                   <a:srgbClr val="B0C8F0"/>
                 </a:solidFill>
               </a:rPr>
-              <a:t>CI/CD Platform  |  Project Summary</a:t>
+              <a:t>Project Summary  |  Solution Architect Presentation</a:t>
             </a:r>
           </a:p>
         </p:txBody>
@@ -3336,8 +3336,8 @@
         </p:nvSpPr>
         <p:spPr>
           <a:xfrm>
-            <a:off x="8686800" y="91440"/>
-            <a:ext cx="3291840" cy="347472"/>
+            <a:off x="8138160" y="91440"/>
+            <a:ext cx="3840480" cy="731520"/>
           </a:xfrm>
           <a:prstGeom prst="rect">
             <a:avLst/>
@@ -3360,61 +3360,51 @@
               <a:t>Programme Project Review</a:t>
             </a:r>
           </a:p>
-        </p:txBody>
-      </p:sp>
-      <p:sp>
-        <p:nvSpPr>
-          <p:cNvPr id="9" name="TextBox 8"/>
-          <p:cNvSpPr txBox="1"/>
-          <p:nvPr/>
-        </p:nvSpPr>
-        <p:spPr>
-          <a:xfrm>
-            <a:off x="8686800" y="438912"/>
-            <a:ext cx="3291840" cy="347472"/>
-          </a:xfrm>
-          <a:prstGeom prst="rect">
-            <a:avLst/>
-          </a:prstGeom>
-          <a:noFill/>
-        </p:spPr>
-        <p:txBody>
-          <a:bodyPr wrap="square">
-            <a:spAutoFit/>
-          </a:bodyPr>
-          <a:lstStyle/>
           <a:p>
             <a:pPr algn="r"/>
             <a:r>
-              <a:rPr sz="900" b="0" i="0">
-                <a:solidFill>
-                  <a:srgbClr val="80A0D0"/>
+              <a:rPr sz="850" b="0" i="0">
+                <a:solidFill>
+                  <a:srgbClr val="88AAD0"/>
                 </a:solidFill>
               </a:rPr>
-              <a:t>June 2026  |  Platform Engineering</a:t>
-            </a:r>
-          </a:p>
-        </p:txBody>
-      </p:sp>
-      <p:sp>
-        <p:nvSpPr>
-          <p:cNvPr id="10" name="Rectangle 9"/>
+              <a:t>Platform Engineering Team</a:t>
+            </a:r>
+          </a:p>
+          <a:p>
+            <a:pPr algn="r"/>
+            <a:r>
+              <a:rPr sz="850" b="0" i="0">
+                <a:solidFill>
+                  <a:srgbClr val="88AAD0"/>
+                </a:solidFill>
+              </a:rPr>
+              <a:t>June 2026</a:t>
+            </a:r>
+          </a:p>
+        </p:txBody>
+      </p:sp>
+      <p:sp>
+        <p:nvSpPr>
+          <p:cNvPr id="9" name="Rectangle 8"/>
           <p:cNvSpPr/>
           <p:nvPr/>
         </p:nvSpPr>
         <p:spPr>
           <a:xfrm>
-            <a:off x="146304" y="1042415"/>
-            <a:ext cx="3840480" cy="274320"/>
+            <a:off x="146304" y="996696"/>
+            <a:ext cx="3813048" cy="1847088"/>
           </a:xfrm>
           <a:prstGeom prst="rect">
             <a:avLst/>
           </a:prstGeom>
           <a:solidFill>
-            <a:srgbClr val="1A4A8A"/>
+            <a:srgbClr val="FFFFFF"/>
           </a:solidFill>
-          <a:ln>
-            <a:noFill/>
+          <a:ln w="6350">
+            <a:solidFill>
+              <a:srgbClr val="CCD6E8"/>
+            </a:solidFill>
           </a:ln>
         </p:spPr>
         <p:style>
@@ -3441,54 +3431,20 @@
       </p:sp>
       <p:sp>
         <p:nvSpPr>
-          <p:cNvPr id="11" name="TextBox 10"/>
-          <p:cNvSpPr txBox="1"/>
-          <p:nvPr/>
-        </p:nvSpPr>
-        <p:spPr>
-          <a:xfrm>
-            <a:off x="237744" y="1060704"/>
-            <a:ext cx="3703320" cy="256032"/>
-          </a:xfrm>
-          <a:prstGeom prst="rect">
-            <a:avLst/>
-          </a:prstGeom>
-          <a:noFill/>
-        </p:spPr>
-        <p:txBody>
-          <a:bodyPr wrap="square">
-            <a:spAutoFit/>
-          </a:bodyPr>
-          <a:lstStyle/>
-          <a:p>
-            <a:pPr algn="l"/>
-            <a:r>
-              <a:rPr sz="900" b="1" i="0">
-                <a:solidFill>
-                  <a:srgbClr val="FFFFFF"/>
-                </a:solidFill>
-              </a:rPr>
-              <a:t>📌  SCOPE</a:t>
-            </a:r>
-          </a:p>
-        </p:txBody>
-      </p:sp>
-      <p:sp>
-        <p:nvSpPr>
-          <p:cNvPr id="12" name="Rectangle 11"/>
+          <p:cNvPr id="10" name="Rectangle 9"/>
           <p:cNvSpPr/>
           <p:nvPr/>
         </p:nvSpPr>
         <p:spPr>
           <a:xfrm>
-            <a:off x="146304" y="1316736"/>
-            <a:ext cx="3840480" cy="1719072"/>
+            <a:off x="146304" y="996696"/>
+            <a:ext cx="3813048" cy="260603"/>
           </a:xfrm>
           <a:prstGeom prst="rect">
             <a:avLst/>
           </a:prstGeom>
           <a:solidFill>
-            <a:srgbClr val="FFFFFF"/>
+            <a:srgbClr val="163A78"/>
           </a:solidFill>
           <a:ln>
             <a:noFill/>
@@ -3518,14 +3474,14 @@
       </p:sp>
       <p:sp>
         <p:nvSpPr>
-          <p:cNvPr id="13" name="TextBox 12"/>
+          <p:cNvPr id="11" name="TextBox 10"/>
           <p:cNvSpPr txBox="1"/>
           <p:nvPr/>
         </p:nvSpPr>
         <p:spPr>
           <a:xfrm>
-            <a:off x="237744" y="1371600"/>
-            <a:ext cx="3675888" cy="1627631"/>
+            <a:off x="256032" y="1024128"/>
+            <a:ext cx="3648456" cy="224027"/>
           </a:xfrm>
           <a:prstGeom prst="rect">
             <a:avLst/>
@@ -3540,18 +3496,52 @@
           <a:p>
             <a:pPr algn="l"/>
             <a:r>
-              <a:rPr sz="750" b="1">
+              <a:rPr sz="900" b="1" i="0">
+                <a:solidFill>
+                  <a:srgbClr val="FFFFFF"/>
+                </a:solidFill>
+              </a:rPr>
+              <a:t>📌   Scope</a:t>
+            </a:r>
+          </a:p>
+        </p:txBody>
+      </p:sp>
+      <p:sp>
+        <p:nvSpPr>
+          <p:cNvPr id="12" name="TextBox 11"/>
+          <p:cNvSpPr txBox="1"/>
+          <p:nvPr/>
+        </p:nvSpPr>
+        <p:spPr>
+          <a:xfrm>
+            <a:off x="274320" y="1312164"/>
+            <a:ext cx="3593591" cy="1495044"/>
+          </a:xfrm>
+          <a:prstGeom prst="rect">
+            <a:avLst/>
+          </a:prstGeom>
+          <a:noFill/>
+        </p:spPr>
+        <p:txBody>
+          <a:bodyPr wrap="square">
+            <a:spAutoFit/>
+          </a:bodyPr>
+          <a:lstStyle/>
+          <a:p>
+            <a:pPr algn="l"/>
+            <a:r>
+              <a:rPr sz="800" b="0" i="0">
                 <a:solidFill>
                   <a:srgbClr val="1A1A2E"/>
                 </a:solidFill>
               </a:rPr>
-              <a:t>Phase 1 – App as Code CI/CD Platform (FROZEN BASELINE v1.0)</a:t>
+              <a:t>The App as Code project establishes a fully automated, policy-governed CI/CD platform for BA Opco application workloads migrating to AWS. The platform removes manual intervention from the deployment lifecycle and enforces compliance at every stage.</a:t>
             </a:r>
           </a:p>
           <a:p>
             <a:pPr algn="l"/>
             <a:r>
-              <a:rPr sz="750" b="0">
+              <a:rPr sz="400" b="0" i="0">
                 <a:solidFill>
                   <a:srgbClr val="1A1A2E"/>
                 </a:solidFill>
@@ -3562,84 +3552,29 @@
           <a:p>
             <a:pPr algn="l"/>
             <a:r>
-              <a:rPr sz="750" b="1">
+              <a:rPr sz="800" b="1" i="0">
                 <a:solidFill>
                   <a:srgbClr val="1A1A2E"/>
                 </a:solidFill>
               </a:rPr>
-              <a:t>In Scope</a:t>
+              <a:t>What the platform delivers:</a:t>
             </a:r>
           </a:p>
           <a:p>
             <a:pPr algn="l"/>
             <a:r>
-              <a:rPr sz="750" b="0">
+              <a:rPr sz="800" b="0" i="0">
                 <a:solidFill>
                   <a:srgbClr val="1A1A2E"/>
                 </a:solidFill>
               </a:rPr>
-              <a:t>• GitHub Actions CI/CD: build → scan → test → release → promote</a:t>
+              <a:t>End-to-end pipeline automation from code commit through to production deployment, spanning build, security scanning, infrastructure provisioning, and environment promotion (dev → test → prod).</a:t>
             </a:r>
           </a:p>
           <a:p>
             <a:pPr algn="l"/>
             <a:r>
-              <a:rPr sz="750" b="0">
-                <a:solidFill>
-                  <a:srgbClr val="1A1A2E"/>
-                </a:solidFill>
-              </a:rPr>
-              <a:t>• Golden AMI build (Ansible) + IaC provisioning (Terraform)</a:t>
-            </a:r>
-          </a:p>
-          <a:p>
-            <a:pPr algn="l"/>
-            <a:r>
-              <a:rPr sz="750" b="0">
-                <a:solidFill>
-                  <a:srgbClr val="1A1A2E"/>
-                </a:solidFill>
-              </a:rPr>
-              <a:t>• Security gates: SAST, secret scan, image scan (ECR/Inspector)</a:t>
-            </a:r>
-          </a:p>
-          <a:p>
-            <a:pPr algn="l"/>
-            <a:r>
-              <a:rPr sz="750" b="0">
-                <a:solidFill>
-                  <a:srgbClr val="1A1A2E"/>
-                </a:solidFill>
-              </a:rPr>
-              <a:t>• Environments: dev → test → prod with approval gates</a:t>
-            </a:r>
-          </a:p>
-          <a:p>
-            <a:pPr algn="l"/>
-            <a:r>
-              <a:rPr sz="750" b="0">
-                <a:solidFill>
-                  <a:srgbClr val="1A1A2E"/>
-                </a:solidFill>
-              </a:rPr>
-              <a:t>• Drift detection, auto-remediation &amp; compliance evidence (S3)</a:t>
-            </a:r>
-          </a:p>
-          <a:p>
-            <a:pPr algn="l"/>
-            <a:r>
-              <a:rPr sz="750" b="0">
-                <a:solidFill>
-                  <a:srgbClr val="1A1A2E"/>
-                </a:solidFill>
-              </a:rPr>
-              <a:t>• Runtimes: WebLogic→Tomcat migration, Apache Tomcat, Python</a:t>
-            </a:r>
-          </a:p>
-          <a:p>
-            <a:pPr algn="l"/>
-            <a:r>
-              <a:rPr sz="750" b="0">
+              <a:rPr sz="300" b="0" i="0">
                 <a:solidFill>
                   <a:srgbClr val="1A1A2E"/>
                 </a:solidFill>
@@ -3650,57 +3585,59 @@
           <a:p>
             <a:pPr algn="l"/>
             <a:r>
-              <a:rPr sz="750" b="1">
+              <a:rPr sz="800" b="0" i="0">
                 <a:solidFill>
                   <a:srgbClr val="1A1A2E"/>
                 </a:solidFill>
               </a:rPr>
-              <a:t>Out of Scope (Phase 1)</a:t>
+              <a:t>Supported runtimes include Apache Tomcat, Python, and WebLogic (transitioning to Tomcat). Deployments are governed by a frozen architecture baseline (v1.0, June 2026) and a fully traceable Requirement Traceability Matrix.</a:t>
             </a:r>
           </a:p>
           <a:p>
             <a:pPr algn="l"/>
             <a:r>
-              <a:rPr sz="750" b="0">
+              <a:rPr sz="300" b="0" i="0">
                 <a:solidFill>
                   <a:srgbClr val="1A1A2E"/>
                 </a:solidFill>
               </a:rPr>
-              <a:t>• ServiceNow integration (Phase 2)</a:t>
+              <a:t/>
             </a:r>
           </a:p>
           <a:p>
             <a:pPr algn="l"/>
             <a:r>
-              <a:rPr sz="750" b="0">
-                <a:solidFill>
-                  <a:srgbClr val="1A1A2E"/>
+              <a:rPr sz="800" b="0" i="1">
+                <a:solidFill>
+                  <a:srgbClr val="3A4A6A"/>
                 </a:solidFill>
               </a:rPr>
-              <a:t>• Digital signature controls  |  App source-code logic/testing</a:t>
-            </a:r>
-          </a:p>
-        </p:txBody>
-      </p:sp>
-      <p:sp>
-        <p:nvSpPr>
-          <p:cNvPr id="14" name="Rectangle 13"/>
+              <a:t>Phase 2 items: ServiceNow integration and detailed FR-04 evidence reporting are deferred for further clarification.</a:t>
+            </a:r>
+          </a:p>
+        </p:txBody>
+      </p:sp>
+      <p:sp>
+        <p:nvSpPr>
+          <p:cNvPr id="13" name="Rectangle 12"/>
           <p:cNvSpPr/>
           <p:nvPr/>
         </p:nvSpPr>
         <p:spPr>
           <a:xfrm>
-            <a:off x="4133088" y="1042415"/>
-            <a:ext cx="3840480" cy="274320"/>
+            <a:off x="4105656" y="996696"/>
+            <a:ext cx="3813048" cy="1847088"/>
           </a:xfrm>
           <a:prstGeom prst="rect">
             <a:avLst/>
           </a:prstGeom>
           <a:solidFill>
-            <a:srgbClr val="1A4A8A"/>
+            <a:srgbClr val="FFFFFF"/>
           </a:solidFill>
-          <a:ln>
-            <a:noFill/>
+          <a:ln w="6350">
+            <a:solidFill>
+              <a:srgbClr val="CCD6E8"/>
+            </a:solidFill>
           </a:ln>
         </p:spPr>
         <p:style>
@@ -3727,54 +3664,20 @@
       </p:sp>
       <p:sp>
         <p:nvSpPr>
-          <p:cNvPr id="15" name="TextBox 14"/>
-          <p:cNvSpPr txBox="1"/>
-          <p:nvPr/>
-        </p:nvSpPr>
-        <p:spPr>
-          <a:xfrm>
-            <a:off x="4224528" y="1060704"/>
-            <a:ext cx="3703320" cy="256032"/>
-          </a:xfrm>
-          <a:prstGeom prst="rect">
-            <a:avLst/>
-          </a:prstGeom>
-          <a:noFill/>
-        </p:spPr>
-        <p:txBody>
-          <a:bodyPr wrap="square">
-            <a:spAutoFit/>
-          </a:bodyPr>
-          <a:lstStyle/>
-          <a:p>
-            <a:pPr algn="l"/>
-            <a:r>
-              <a:rPr sz="900" b="1" i="0">
-                <a:solidFill>
-                  <a:srgbClr val="FFFFFF"/>
-                </a:solidFill>
-              </a:rPr>
-              <a:t>📅  PROJECT PLAN</a:t>
-            </a:r>
-          </a:p>
-        </p:txBody>
-      </p:sp>
-      <p:sp>
-        <p:nvSpPr>
-          <p:cNvPr id="16" name="Rectangle 15"/>
+          <p:cNvPr id="14" name="Rectangle 13"/>
           <p:cNvSpPr/>
           <p:nvPr/>
         </p:nvSpPr>
         <p:spPr>
           <a:xfrm>
-            <a:off x="4133088" y="1316736"/>
-            <a:ext cx="3840480" cy="1719072"/>
+            <a:off x="4105656" y="996696"/>
+            <a:ext cx="3813048" cy="260603"/>
           </a:xfrm>
           <a:prstGeom prst="rect">
             <a:avLst/>
           </a:prstGeom>
           <a:solidFill>
-            <a:srgbClr val="FFFFFF"/>
+            <a:srgbClr val="163A78"/>
           </a:solidFill>
           <a:ln>
             <a:noFill/>
@@ -3804,14 +3707,14 @@
       </p:sp>
       <p:sp>
         <p:nvSpPr>
-          <p:cNvPr id="17" name="TextBox 16"/>
+          <p:cNvPr id="15" name="TextBox 14"/>
           <p:cNvSpPr txBox="1"/>
           <p:nvPr/>
         </p:nvSpPr>
         <p:spPr>
           <a:xfrm>
-            <a:off x="4224528" y="1371600"/>
-            <a:ext cx="3675888" cy="1627631"/>
+            <a:off x="4215384" y="1024128"/>
+            <a:ext cx="3648456" cy="224027"/>
           </a:xfrm>
           <a:prstGeom prst="rect">
             <a:avLst/>
@@ -3826,95 +3729,52 @@
           <a:p>
             <a:pPr algn="l"/>
             <a:r>
-              <a:rPr sz="750" b="1">
+              <a:rPr sz="900" b="1" i="0">
+                <a:solidFill>
+                  <a:srgbClr val="FFFFFF"/>
+                </a:solidFill>
+              </a:rPr>
+              <a:t>📅   Project Plan</a:t>
+            </a:r>
+          </a:p>
+        </p:txBody>
+      </p:sp>
+      <p:sp>
+        <p:nvSpPr>
+          <p:cNvPr id="16" name="TextBox 15"/>
+          <p:cNvSpPr txBox="1"/>
+          <p:nvPr/>
+        </p:nvSpPr>
+        <p:spPr>
+          <a:xfrm>
+            <a:off x="4233672" y="1312164"/>
+            <a:ext cx="3593591" cy="1495044"/>
+          </a:xfrm>
+          <a:prstGeom prst="rect">
+            <a:avLst/>
+          </a:prstGeom>
+          <a:noFill/>
+        </p:spPr>
+        <p:txBody>
+          <a:bodyPr wrap="square">
+            <a:spAutoFit/>
+          </a:bodyPr>
+          <a:lstStyle/>
+          <a:p>
+            <a:pPr algn="l"/>
+            <a:r>
+              <a:rPr sz="800" b="0" i="0">
                 <a:solidFill>
                   <a:srgbClr val="1A1A2E"/>
                 </a:solidFill>
               </a:rPr>
-              <a:t>Milestone</a:t>
+              <a:t>The architecture baseline was formally frozen in June 2026, with all component diagrams, the C4 model, and the Requirement Traceability Matrix fully completed and signed off.</a:t>
             </a:r>
           </a:p>
           <a:p>
             <a:pPr algn="l"/>
             <a:r>
-              <a:rPr sz="750" b="0">
-                <a:solidFill>
-                  <a:srgbClr val="1A1A2E"/>
-                </a:solidFill>
-              </a:rPr>
-              <a:t>✅ Architecture Baseline frozen (v1.0 – Jun 2026)</a:t>
-            </a:r>
-          </a:p>
-          <a:p>
-            <a:pPr algn="l"/>
-            <a:r>
-              <a:rPr sz="750" b="0">
-                <a:solidFill>
-                  <a:srgbClr val="1A1A2E"/>
-                </a:solidFill>
-              </a:rPr>
-              <a:t>✅ Component context + C4 diagrams complete</a:t>
-            </a:r>
-          </a:p>
-          <a:p>
-            <a:pPr algn="l"/>
-            <a:r>
-              <a:rPr sz="750" b="0">
-                <a:solidFill>
-                  <a:srgbClr val="1A1A2E"/>
-                </a:solidFill>
-              </a:rPr>
-              <a:t>✅ Requirement Traceability Matrix (001–008) met</a:t>
-            </a:r>
-          </a:p>
-          <a:p>
-            <a:pPr algn="l"/>
-            <a:r>
-              <a:rPr sz="750" b="0">
-                <a:solidFill>
-                  <a:srgbClr val="1A1A2E"/>
-                </a:solidFill>
-              </a:rPr>
-              <a:t>✅ Pipeline scaffold + Terraform / Ansible ready</a:t>
-            </a:r>
-          </a:p>
-          <a:p>
-            <a:pPr algn="l"/>
-            <a:r>
-              <a:rPr sz="750" b="0">
-                <a:solidFill>
-                  <a:srgbClr val="1A1A2E"/>
-                </a:solidFill>
-              </a:rPr>
-              <a:t>🔄 POC – Tomcat ECS/Fargate (in progress)</a:t>
-            </a:r>
-          </a:p>
-          <a:p>
-            <a:pPr algn="l"/>
-            <a:r>
-              <a:rPr sz="750" b="0">
-                <a:solidFill>
-                  <a:srgbClr val="1A1A2E"/>
-                </a:solidFill>
-              </a:rPr>
-              <a:t>⬜ ServiceNow integration (Phase 2)</a:t>
-            </a:r>
-          </a:p>
-          <a:p>
-            <a:pPr algn="l"/>
-            <a:r>
-              <a:rPr sz="750" b="0">
-                <a:solidFill>
-                  <a:srgbClr val="1A1A2E"/>
-                </a:solidFill>
-              </a:rPr>
-              <a:t>⬜ Newcastle Workshop – Show &amp; Tell</a:t>
-            </a:r>
-          </a:p>
-          <a:p>
-            <a:pPr algn="l"/>
-            <a:r>
-              <a:rPr sz="750" b="0">
+              <a:rPr sz="300" b="0" i="0">
                 <a:solidFill>
                   <a:srgbClr val="1A1A2E"/>
                 </a:solidFill>
@@ -3925,57 +3785,81 @@
           <a:p>
             <a:pPr algn="l"/>
             <a:r>
-              <a:rPr sz="750" b="1">
+              <a:rPr sz="800" b="0" i="0">
                 <a:solidFill>
                   <a:srgbClr val="1A1A2E"/>
                 </a:solidFill>
               </a:rPr>
-              <a:t>Promotion Model</a:t>
+              <a:t>The CI/CD pipeline scaffold, Terraform infrastructure modules, and Ansible-based golden AMI build process are in place and ready for application onboarding.</a:t>
             </a:r>
           </a:p>
           <a:p>
             <a:pPr algn="l"/>
             <a:r>
-              <a:rPr sz="750" b="0">
+              <a:rPr sz="300" b="0" i="0">
                 <a:solidFill>
                   <a:srgbClr val="1A1A2E"/>
                 </a:solidFill>
               </a:rPr>
-              <a:t>dev (auto)  →  test (quality gate)  →  prod (manual approval)</a:t>
+              <a:t/>
             </a:r>
           </a:p>
           <a:p>
             <a:pPr algn="l"/>
             <a:r>
-              <a:rPr sz="750" b="0">
+              <a:rPr sz="800" b="0" i="0">
                 <a:solidFill>
                   <a:srgbClr val="1A1A2E"/>
                 </a:solidFill>
               </a:rPr>
-              <a:t>Fail-closed: rejected release IDs blocked via SSM Decision Records</a:t>
-            </a:r>
-          </a:p>
-        </p:txBody>
-      </p:sp>
-      <p:sp>
-        <p:nvSpPr>
-          <p:cNvPr id="18" name="Rectangle 17"/>
+              <a:t>Currently in progress: a Proof of Concept is under way to validate the end-to-end pipeline by deploying Apache Tomcat to Amazon ECS Fargate without any developer access to the AWS Console.</a:t>
+            </a:r>
+          </a:p>
+          <a:p>
+            <a:pPr algn="l"/>
+            <a:r>
+              <a:rPr sz="300" b="0" i="0">
+                <a:solidFill>
+                  <a:srgbClr val="1A1A2E"/>
+                </a:solidFill>
+              </a:rPr>
+              <a:t/>
+            </a:r>
+          </a:p>
+          <a:p>
+            <a:pPr algn="l"/>
+            <a:r>
+              <a:rPr sz="800" b="0" i="0">
+                <a:solidFill>
+                  <a:srgbClr val="1A1A2E"/>
+                </a:solidFill>
+              </a:rPr>
+              <a:t>Upcoming milestones include the Newcastle Workshop Show &amp; Tell and the Phase 2 ServiceNow integration.</a:t>
+            </a:r>
+          </a:p>
+        </p:txBody>
+      </p:sp>
+      <p:sp>
+        <p:nvSpPr>
+          <p:cNvPr id="17" name="Rectangle 16"/>
           <p:cNvSpPr/>
           <p:nvPr/>
         </p:nvSpPr>
         <p:spPr>
           <a:xfrm>
-            <a:off x="8119872" y="1042415"/>
-            <a:ext cx="3840480" cy="274320"/>
+            <a:off x="8065008" y="996696"/>
+            <a:ext cx="3813048" cy="1847088"/>
           </a:xfrm>
           <a:prstGeom prst="rect">
             <a:avLst/>
           </a:prstGeom>
           <a:solidFill>
-            <a:srgbClr val="1A4A8A"/>
+            <a:srgbClr val="FFFFFF"/>
           </a:solidFill>
-          <a:ln>
-            <a:noFill/>
+          <a:ln w="6350">
+            <a:solidFill>
+              <a:srgbClr val="CCD6E8"/>
+            </a:solidFill>
           </a:ln>
         </p:spPr>
         <p:style>
@@ -4002,54 +3886,20 @@
       </p:sp>
       <p:sp>
         <p:nvSpPr>
-          <p:cNvPr id="19" name="TextBox 18"/>
-          <p:cNvSpPr txBox="1"/>
-          <p:nvPr/>
-        </p:nvSpPr>
-        <p:spPr>
-          <a:xfrm>
-            <a:off x="8211312" y="1060704"/>
-            <a:ext cx="3703320" cy="256032"/>
-          </a:xfrm>
-          <a:prstGeom prst="rect">
-            <a:avLst/>
-          </a:prstGeom>
-          <a:noFill/>
-        </p:spPr>
-        <p:txBody>
-          <a:bodyPr wrap="square">
-            <a:spAutoFit/>
-          </a:bodyPr>
-          <a:lstStyle/>
-          <a:p>
-            <a:pPr algn="l"/>
-            <a:r>
-              <a:rPr sz="900" b="1" i="0">
-                <a:solidFill>
-                  <a:srgbClr val="FFFFFF"/>
-                </a:solidFill>
-              </a:rPr>
-              <a:t>⚠️  RISKS &amp; ISSUES</a:t>
-            </a:r>
-          </a:p>
-        </p:txBody>
-      </p:sp>
-      <p:sp>
-        <p:nvSpPr>
-          <p:cNvPr id="20" name="Rectangle 19"/>
+          <p:cNvPr id="18" name="Rectangle 17"/>
           <p:cNvSpPr/>
           <p:nvPr/>
         </p:nvSpPr>
         <p:spPr>
           <a:xfrm>
-            <a:off x="8119872" y="1316736"/>
-            <a:ext cx="3840480" cy="1719072"/>
+            <a:off x="8065008" y="996696"/>
+            <a:ext cx="3813048" cy="260603"/>
           </a:xfrm>
           <a:prstGeom prst="rect">
             <a:avLst/>
           </a:prstGeom>
           <a:solidFill>
-            <a:srgbClr val="FFFFFF"/>
+            <a:srgbClr val="163A78"/>
           </a:solidFill>
           <a:ln>
             <a:noFill/>
@@ -4079,14 +3929,14 @@
       </p:sp>
       <p:sp>
         <p:nvSpPr>
-          <p:cNvPr id="21" name="TextBox 20"/>
+          <p:cNvPr id="19" name="TextBox 18"/>
           <p:cNvSpPr txBox="1"/>
           <p:nvPr/>
         </p:nvSpPr>
         <p:spPr>
           <a:xfrm>
-            <a:off x="8211312" y="1371600"/>
-            <a:ext cx="3675888" cy="1627631"/>
+            <a:off x="8174736" y="1024128"/>
+            <a:ext cx="3648456" cy="224027"/>
           </a:xfrm>
           <a:prstGeom prst="rect">
             <a:avLst/>
@@ -4101,73 +3951,52 @@
           <a:p>
             <a:pPr algn="l"/>
             <a:r>
-              <a:rPr sz="750" b="1">
+              <a:rPr sz="900" b="1" i="0">
+                <a:solidFill>
+                  <a:srgbClr val="FFFFFF"/>
+                </a:solidFill>
+              </a:rPr>
+              <a:t>⚠️   Risks &amp; Issues</a:t>
+            </a:r>
+          </a:p>
+        </p:txBody>
+      </p:sp>
+      <p:sp>
+        <p:nvSpPr>
+          <p:cNvPr id="20" name="TextBox 19"/>
+          <p:cNvSpPr txBox="1"/>
+          <p:nvPr/>
+        </p:nvSpPr>
+        <p:spPr>
+          <a:xfrm>
+            <a:off x="8193024" y="1312164"/>
+            <a:ext cx="3593591" cy="1495044"/>
+          </a:xfrm>
+          <a:prstGeom prst="rect">
+            <a:avLst/>
+          </a:prstGeom>
+          <a:noFill/>
+        </p:spPr>
+        <p:txBody>
+          <a:bodyPr wrap="square">
+            <a:spAutoFit/>
+          </a:bodyPr>
+          <a:lstStyle/>
+          <a:p>
+            <a:pPr algn="l"/>
+            <a:r>
+              <a:rPr sz="800" b="0" i="0">
                 <a:solidFill>
                   <a:srgbClr val="1A1A2E"/>
                 </a:solidFill>
               </a:rPr>
-              <a:t>Risks</a:t>
+              <a:t>Legacy WebLogic applications cannot be containerised directly, because Amazon ECS Fargate does not support the multicast protocol that WebLogic clusters depend upon. These applications must first be migrated to Apache Tomcat.</a:t>
             </a:r>
           </a:p>
           <a:p>
             <a:pPr algn="l"/>
             <a:r>
-              <a:rPr sz="750" b="0">
-                <a:solidFill>
-                  <a:srgbClr val="1A1A2E"/>
-                </a:solidFill>
-              </a:rPr>
-              <a:t>🔴 WebLogic apps: Fargate multicast not supported → must migrate to Tomcat first</a:t>
-            </a:r>
-          </a:p>
-          <a:p>
-            <a:pPr algn="l"/>
-            <a:r>
-              <a:rPr sz="750" b="0">
-                <a:solidFill>
-                  <a:srgbClr val="1A1A2E"/>
-                </a:solidFill>
-              </a:rPr>
-              <a:t>🔴 OAM/Ping IdP apps: must switch to Entra ID before containerisation</a:t>
-            </a:r>
-          </a:p>
-          <a:p>
-            <a:pPr algn="l"/>
-            <a:r>
-              <a:rPr sz="750" b="0">
-                <a:solidFill>
-                  <a:srgbClr val="1A1A2E"/>
-                </a:solidFill>
-              </a:rPr>
-              <a:t>🟡 Windows containers: large image size, limited Fargate support</a:t>
-            </a:r>
-          </a:p>
-          <a:p>
-            <a:pPr algn="l"/>
-            <a:r>
-              <a:rPr sz="750" b="0">
-                <a:solidFill>
-                  <a:srgbClr val="1A1A2E"/>
-                </a:solidFill>
-              </a:rPr>
-              <a:t>🟡 COTS products: vendor support &amp; licensing assessment required</a:t>
-            </a:r>
-          </a:p>
-          <a:p>
-            <a:pPr algn="l"/>
-            <a:r>
-              <a:rPr sz="750" b="0">
-                <a:solidFill>
-                  <a:srgbClr val="1A1A2E"/>
-                </a:solidFill>
-              </a:rPr>
-              <a:t>🟡 Stateful apps: session externalisation to Redis required</a:t>
-            </a:r>
-          </a:p>
-          <a:p>
-            <a:pPr algn="l"/>
-            <a:r>
-              <a:rPr sz="750" b="0">
+              <a:rPr sz="300" b="0" i="0">
                 <a:solidFill>
                   <a:srgbClr val="1A1A2E"/>
                 </a:solidFill>
@@ -4178,68 +4007,81 @@
           <a:p>
             <a:pPr algn="l"/>
             <a:r>
-              <a:rPr sz="750" b="1">
+              <a:rPr sz="800" b="0" i="0">
                 <a:solidFill>
                   <a:srgbClr val="1A1A2E"/>
                 </a:solidFill>
               </a:rPr>
-              <a:t>Issues</a:t>
+              <a:t>Applications currently authenticated via OAM or Ping must transition to Microsoft Entra ID before they can be onboarded, as these are not strategic identity providers.</a:t>
             </a:r>
           </a:p>
           <a:p>
             <a:pPr algn="l"/>
             <a:r>
-              <a:rPr sz="750" b="0">
+              <a:rPr sz="300" b="0" i="0">
                 <a:solidFill>
                   <a:srgbClr val="1A1A2E"/>
                 </a:solidFill>
               </a:rPr>
-              <a:t>⚠️  Terraform ECS/Fargate Tomcat resources not yet provisioned (POC gap)</a:t>
+              <a:t/>
             </a:r>
           </a:p>
           <a:p>
             <a:pPr algn="l"/>
             <a:r>
-              <a:rPr sz="750" b="0">
+              <a:rPr sz="800" b="0" i="0">
                 <a:solidFill>
                   <a:srgbClr val="1A1A2E"/>
                 </a:solidFill>
               </a:rPr>
-              <a:t>⚠️  Deploy-dev job still placeholder – real ECS deployment pending</a:t>
+              <a:t>On the infrastructure side, the Terraform modules for the ECS Fargate runtime have not yet been provisioned, which is the primary gap the current POC is addressing.</a:t>
             </a:r>
           </a:p>
           <a:p>
             <a:pPr algn="l"/>
             <a:r>
-              <a:rPr sz="750" b="0">
+              <a:rPr sz="300" b="0" i="0">
                 <a:solidFill>
                   <a:srgbClr val="1A1A2E"/>
                 </a:solidFill>
               </a:rPr>
-              <a:t>⚠️  FR-04 evidence schema/reporting deferred to Phase 2</a:t>
-            </a:r>
-          </a:p>
-        </p:txBody>
-      </p:sp>
-      <p:sp>
-        <p:nvSpPr>
-          <p:cNvPr id="22" name="Rectangle 21"/>
+              <a:t/>
+            </a:r>
+          </a:p>
+          <a:p>
+            <a:pPr algn="l"/>
+            <a:r>
+              <a:rPr sz="800" b="0" i="1">
+                <a:solidFill>
+                  <a:srgbClr val="3A4A6A"/>
+                </a:solidFill>
+              </a:rPr>
+              <a:t>The FR-04 evidence schema and reporting design remain a Phase 2 item pending stakeholder clarification.</a:t>
+            </a:r>
+          </a:p>
+        </p:txBody>
+      </p:sp>
+      <p:sp>
+        <p:nvSpPr>
+          <p:cNvPr id="21" name="Rectangle 20"/>
           <p:cNvSpPr/>
           <p:nvPr/>
         </p:nvSpPr>
         <p:spPr>
           <a:xfrm>
-            <a:off x="146304" y="2999231"/>
-            <a:ext cx="5806440" cy="274320"/>
+            <a:off x="146304" y="3044952"/>
+            <a:ext cx="5742432" cy="1975104"/>
           </a:xfrm>
           <a:prstGeom prst="rect">
             <a:avLst/>
           </a:prstGeom>
           <a:solidFill>
-            <a:srgbClr val="1A4A8A"/>
+            <a:srgbClr val="FFFFFF"/>
           </a:solidFill>
-          <a:ln>
-            <a:noFill/>
+          <a:ln w="6350">
+            <a:solidFill>
+              <a:srgbClr val="CCD6E8"/>
+            </a:solidFill>
           </a:ln>
         </p:spPr>
         <p:style>
@@ -4266,54 +4108,20 @@
       </p:sp>
       <p:sp>
         <p:nvSpPr>
-          <p:cNvPr id="23" name="TextBox 22"/>
-          <p:cNvSpPr txBox="1"/>
-          <p:nvPr/>
-        </p:nvSpPr>
-        <p:spPr>
-          <a:xfrm>
-            <a:off x="237744" y="3017519"/>
-            <a:ext cx="5669279" cy="256032"/>
-          </a:xfrm>
-          <a:prstGeom prst="rect">
-            <a:avLst/>
-          </a:prstGeom>
-          <a:noFill/>
-        </p:spPr>
-        <p:txBody>
-          <a:bodyPr wrap="square">
-            <a:spAutoFit/>
-          </a:bodyPr>
-          <a:lstStyle/>
-          <a:p>
-            <a:pPr algn="l"/>
-            <a:r>
-              <a:rPr sz="900" b="1" i="0">
-                <a:solidFill>
-                  <a:srgbClr val="FFFFFF"/>
-                </a:solidFill>
-              </a:rPr>
-              <a:t>🔗  DEPENDENCIES</a:t>
-            </a:r>
-          </a:p>
-        </p:txBody>
-      </p:sp>
-      <p:sp>
-        <p:nvSpPr>
-          <p:cNvPr id="24" name="Rectangle 23"/>
+          <p:cNvPr id="22" name="Rectangle 21"/>
           <p:cNvSpPr/>
           <p:nvPr/>
         </p:nvSpPr>
         <p:spPr>
           <a:xfrm>
-            <a:off x="146304" y="3273551"/>
-            <a:ext cx="5806440" cy="1883664"/>
+            <a:off x="146304" y="3044952"/>
+            <a:ext cx="5742432" cy="260603"/>
           </a:xfrm>
           <a:prstGeom prst="rect">
             <a:avLst/>
           </a:prstGeom>
           <a:solidFill>
-            <a:srgbClr val="FFFFFF"/>
+            <a:srgbClr val="163A78"/>
           </a:solidFill>
           <a:ln>
             <a:noFill/>
@@ -4343,14 +4151,14 @@
       </p:sp>
       <p:sp>
         <p:nvSpPr>
-          <p:cNvPr id="25" name="TextBox 24"/>
+          <p:cNvPr id="23" name="TextBox 22"/>
           <p:cNvSpPr txBox="1"/>
           <p:nvPr/>
         </p:nvSpPr>
         <p:spPr>
           <a:xfrm>
-            <a:off x="237744" y="3328415"/>
-            <a:ext cx="5641848" cy="1792224"/>
+            <a:off x="256032" y="3072384"/>
+            <a:ext cx="5577840" cy="224027"/>
           </a:xfrm>
           <a:prstGeom prst="rect">
             <a:avLst/>
@@ -4365,51 +4173,52 @@
           <a:p>
             <a:pPr algn="l"/>
             <a:r>
-              <a:rPr sz="750" b="1">
+              <a:rPr sz="900" b="1" i="0">
+                <a:solidFill>
+                  <a:srgbClr val="FFFFFF"/>
+                </a:solidFill>
+              </a:rPr>
+              <a:t>🔗   Dependencies</a:t>
+            </a:r>
+          </a:p>
+        </p:txBody>
+      </p:sp>
+      <p:sp>
+        <p:nvSpPr>
+          <p:cNvPr id="24" name="TextBox 23"/>
+          <p:cNvSpPr txBox="1"/>
+          <p:nvPr/>
+        </p:nvSpPr>
+        <p:spPr>
+          <a:xfrm>
+            <a:off x="274320" y="3360420"/>
+            <a:ext cx="5522976" cy="1623060"/>
+          </a:xfrm>
+          <a:prstGeom prst="rect">
+            <a:avLst/>
+          </a:prstGeom>
+          <a:noFill/>
+        </p:spPr>
+        <p:txBody>
+          <a:bodyPr wrap="square">
+            <a:spAutoFit/>
+          </a:bodyPr>
+          <a:lstStyle/>
+          <a:p>
+            <a:pPr algn="l"/>
+            <a:r>
+              <a:rPr sz="800" b="0" i="0">
                 <a:solidFill>
                   <a:srgbClr val="1A1A2E"/>
                 </a:solidFill>
               </a:rPr>
-              <a:t>AWS Platform</a:t>
+              <a:t>Successful delivery of the platform depends on a number of items being in place before application teams can onboard.</a:t>
             </a:r>
           </a:p>
           <a:p>
             <a:pPr algn="l"/>
             <a:r>
-              <a:rPr sz="750" b="0">
-                <a:solidFill>
-                  <a:srgbClr val="1A1A2E"/>
-                </a:solidFill>
-              </a:rPr>
-              <a:t>• AWS OIDC trust configured per env (dev / test / prod accounts)</a:t>
-            </a:r>
-          </a:p>
-          <a:p>
-            <a:pPr algn="l"/>
-            <a:r>
-              <a:rPr sz="750" b="0">
-                <a:solidFill>
-                  <a:srgbClr val="1A1A2E"/>
-                </a:solidFill>
-              </a:rPr>
-              <a:t>• IAM roles: AWS_DEV / TEST / PROD_ROLE_ARN provided</a:t>
-            </a:r>
-          </a:p>
-          <a:p>
-            <a:pPr algn="l"/>
-            <a:r>
-              <a:rPr sz="750" b="0">
-                <a:solidFill>
-                  <a:srgbClr val="1A1A2E"/>
-                </a:solidFill>
-              </a:rPr>
-              <a:t>• VPC / subnets / SGs pre-provisioned before POC execution</a:t>
-            </a:r>
-          </a:p>
-          <a:p>
-            <a:pPr algn="l"/>
-            <a:r>
-              <a:rPr sz="750" b="0">
+              <a:rPr sz="300" b="0" i="0">
                 <a:solidFill>
                   <a:srgbClr val="1A1A2E"/>
                 </a:solidFill>
@@ -4420,40 +4229,29 @@
           <a:p>
             <a:pPr algn="l"/>
             <a:r>
-              <a:rPr sz="750" b="1">
+              <a:rPr sz="800" b="1" i="0">
                 <a:solidFill>
                   <a:srgbClr val="1A1A2E"/>
                 </a:solidFill>
               </a:rPr>
-              <a:t>Identity &amp; Access</a:t>
+              <a:t>AWS platform readiness:</a:t>
             </a:r>
           </a:p>
           <a:p>
             <a:pPr algn="l"/>
             <a:r>
-              <a:rPr sz="750" b="0">
+              <a:rPr sz="800" b="0" i="0">
                 <a:solidFill>
                   <a:srgbClr val="1A1A2E"/>
                 </a:solidFill>
               </a:rPr>
-              <a:t>• Microsoft Entra ID app registration (Identity team)</a:t>
+              <a:t>Each deployment environment (dev, test, and prod) must have AWS IAM OIDC trust configured so that GitHub Actions can assume the appropriate role without long-lived credentials. Network foundations — VPCs, subnets, and security groups — must be pre-provisioned ahead of the Terraform pipeline runs.</a:t>
             </a:r>
           </a:p>
           <a:p>
             <a:pPr algn="l"/>
             <a:r>
-              <a:rPr sz="750" b="0">
-                <a:solidFill>
-                  <a:srgbClr val="1A1A2E"/>
-                </a:solidFill>
-              </a:rPr>
-              <a:t>• All non-Entra IdPs (OAM, Ping) must migrate before onboarding</a:t>
-            </a:r>
-          </a:p>
-          <a:p>
-            <a:pPr algn="l"/>
-            <a:r>
-              <a:rPr sz="750" b="0">
+              <a:rPr sz="300" b="0" i="0">
                 <a:solidFill>
                   <a:srgbClr val="1A1A2E"/>
                 </a:solidFill>
@@ -4464,40 +4262,29 @@
           <a:p>
             <a:pPr algn="l"/>
             <a:r>
-              <a:rPr sz="750" b="1">
+              <a:rPr sz="800" b="1" i="0">
                 <a:solidFill>
                   <a:srgbClr val="1A1A2E"/>
                 </a:solidFill>
               </a:rPr>
-              <a:t>GitHub</a:t>
+              <a:t>Identity:</a:t>
             </a:r>
           </a:p>
           <a:p>
             <a:pPr algn="l"/>
             <a:r>
-              <a:rPr sz="750" b="0">
+              <a:rPr sz="800" b="0" i="0">
                 <a:solidFill>
                   <a:srgbClr val="1A1A2E"/>
                 </a:solidFill>
               </a:rPr>
-              <a:t>• GitHub Environments (dev/test/prod) with required reviewers</a:t>
+              <a:t>Applications that use non-strategic identity providers such as OAM or Ping must complete their migration to Microsoft Entra ID, in coordination with the Identity team, before they can be onboarded to the platform.</a:t>
             </a:r>
           </a:p>
           <a:p>
             <a:pPr algn="l"/>
             <a:r>
-              <a:rPr sz="750" b="0">
-                <a:solidFill>
-                  <a:srgbClr val="1A1A2E"/>
-                </a:solidFill>
-              </a:rPr>
-              <a:t>• GitHub Advanced Security enabled (SAST, secret scan, Dependabot)</a:t>
-            </a:r>
-          </a:p>
-          <a:p>
-            <a:pPr algn="l"/>
-            <a:r>
-              <a:rPr sz="750" b="0">
+              <a:rPr sz="300" b="0" i="0">
                 <a:solidFill>
                   <a:srgbClr val="1A1A2E"/>
                 </a:solidFill>
@@ -4508,57 +4295,48 @@
           <a:p>
             <a:pPr algn="l"/>
             <a:r>
-              <a:rPr sz="750" b="1">
+              <a:rPr sz="800" b="1" i="0">
                 <a:solidFill>
                   <a:srgbClr val="1A1A2E"/>
                 </a:solidFill>
               </a:rPr>
-              <a:t>Tooling</a:t>
+              <a:t>Platform tooling:</a:t>
             </a:r>
           </a:p>
           <a:p>
             <a:pPr algn="l"/>
             <a:r>
-              <a:rPr sz="750" b="0">
+              <a:rPr sz="800" b="0" i="0">
                 <a:solidFill>
                   <a:srgbClr val="1A1A2E"/>
                 </a:solidFill>
               </a:rPr>
-              <a:t>• Terraform backend (S3 + DynamoDB) per env  |  Datadog account</a:t>
-            </a:r>
-          </a:p>
-          <a:p>
-            <a:pPr algn="l"/>
-            <a:r>
-              <a:rPr sz="750" b="0">
-                <a:solidFill>
-                  <a:srgbClr val="1A1A2E"/>
-                </a:solidFill>
-              </a:rPr>
-              <a:t>• Amazon Inspector + ECR scanning  |  tfsec + Checkov</a:t>
-            </a:r>
-          </a:p>
-        </p:txBody>
-      </p:sp>
-      <p:sp>
-        <p:nvSpPr>
-          <p:cNvPr id="26" name="Rectangle 25"/>
+              <a:t>GitHub Environments with required reviewers, GitHub Advanced Security, an Amazon ECR registry, Datadog, Amazon Inspector, and the Terraform state backend (S3) must all be configured and available.</a:t>
+            </a:r>
+          </a:p>
+        </p:txBody>
+      </p:sp>
+      <p:sp>
+        <p:nvSpPr>
+          <p:cNvPr id="25" name="Rectangle 24"/>
           <p:cNvSpPr/>
           <p:nvPr/>
         </p:nvSpPr>
         <p:spPr>
           <a:xfrm>
-            <a:off x="6099048" y="2999231"/>
-            <a:ext cx="5943600" cy="274320"/>
+            <a:off x="6071616" y="3044952"/>
+            <a:ext cx="5971032" cy="1975104"/>
           </a:xfrm>
           <a:prstGeom prst="rect">
             <a:avLst/>
           </a:prstGeom>
           <a:solidFill>
-            <a:srgbClr val="1A4A8A"/>
+            <a:srgbClr val="FFFFFF"/>
           </a:solidFill>
-          <a:ln>
-            <a:noFill/>
+          <a:ln w="6350">
+            <a:solidFill>
+              <a:srgbClr val="CCD6E8"/>
+            </a:solidFill>
           </a:ln>
         </p:spPr>
         <p:style>
@@ -4585,54 +4363,20 @@
       </p:sp>
       <p:sp>
         <p:nvSpPr>
-          <p:cNvPr id="27" name="TextBox 26"/>
-          <p:cNvSpPr txBox="1"/>
-          <p:nvPr/>
-        </p:nvSpPr>
-        <p:spPr>
-          <a:xfrm>
-            <a:off x="6190488" y="3017519"/>
-            <a:ext cx="5806440" cy="256032"/>
-          </a:xfrm>
-          <a:prstGeom prst="rect">
-            <a:avLst/>
-          </a:prstGeom>
-          <a:noFill/>
-        </p:spPr>
-        <p:txBody>
-          <a:bodyPr wrap="square">
-            <a:spAutoFit/>
-          </a:bodyPr>
-          <a:lstStyle/>
-          <a:p>
-            <a:pPr algn="l"/>
-            <a:r>
-              <a:rPr sz="900" b="1" i="0">
-                <a:solidFill>
-                  <a:srgbClr val="FFFFFF"/>
-                </a:solidFill>
-              </a:rPr>
-              <a:t>🚀  POC / SHOW &amp; TELL — Tomcat on ECS Fargate</a:t>
-            </a:r>
-          </a:p>
-        </p:txBody>
-      </p:sp>
-      <p:sp>
-        <p:nvSpPr>
-          <p:cNvPr id="28" name="Rectangle 27"/>
+          <p:cNvPr id="26" name="Rectangle 25"/>
           <p:cNvSpPr/>
           <p:nvPr/>
         </p:nvSpPr>
         <p:spPr>
           <a:xfrm>
-            <a:off x="6099048" y="3273551"/>
-            <a:ext cx="5943600" cy="1883664"/>
+            <a:off x="6071616" y="3044952"/>
+            <a:ext cx="5971032" cy="260603"/>
           </a:xfrm>
           <a:prstGeom prst="rect">
             <a:avLst/>
           </a:prstGeom>
           <a:solidFill>
-            <a:srgbClr val="FFFFFF"/>
+            <a:srgbClr val="163A78"/>
           </a:solidFill>
           <a:ln>
             <a:noFill/>
@@ -4662,14 +4406,14 @@
       </p:sp>
       <p:sp>
         <p:nvSpPr>
-          <p:cNvPr id="29" name="TextBox 28"/>
+          <p:cNvPr id="27" name="TextBox 26"/>
           <p:cNvSpPr txBox="1"/>
           <p:nvPr/>
         </p:nvSpPr>
         <p:spPr>
           <a:xfrm>
-            <a:off x="6190488" y="3328415"/>
-            <a:ext cx="5779008" cy="1792224"/>
+            <a:off x="6181344" y="3072384"/>
+            <a:ext cx="5806440" cy="224027"/>
           </a:xfrm>
           <a:prstGeom prst="rect">
             <a:avLst/>
@@ -4684,18 +4428,52 @@
           <a:p>
             <a:pPr algn="l"/>
             <a:r>
-              <a:rPr sz="750" b="1">
+              <a:rPr sz="900" b="1" i="0">
+                <a:solidFill>
+                  <a:srgbClr val="FFFFFF"/>
+                </a:solidFill>
+              </a:rPr>
+              <a:t>🚀   POC / Show &amp; Tell — Tomcat on Amazon ECS Fargate</a:t>
+            </a:r>
+          </a:p>
+        </p:txBody>
+      </p:sp>
+      <p:sp>
+        <p:nvSpPr>
+          <p:cNvPr id="28" name="TextBox 27"/>
+          <p:cNvSpPr txBox="1"/>
+          <p:nvPr/>
+        </p:nvSpPr>
+        <p:spPr>
+          <a:xfrm>
+            <a:off x="6199632" y="3360420"/>
+            <a:ext cx="5751576" cy="1623060"/>
+          </a:xfrm>
+          <a:prstGeom prst="rect">
+            <a:avLst/>
+          </a:prstGeom>
+          <a:noFill/>
+        </p:spPr>
+        <p:txBody>
+          <a:bodyPr wrap="square">
+            <a:spAutoFit/>
+          </a:bodyPr>
+          <a:lstStyle/>
+          <a:p>
+            <a:pPr algn="l"/>
+            <a:r>
+              <a:rPr sz="800" b="0" i="0">
                 <a:solidFill>
                   <a:srgbClr val="1A1A2E"/>
                 </a:solidFill>
               </a:rPr>
-              <a:t>Objective: Prove 'Deployment is a GitHub event – not a human console activity'</a:t>
+              <a:t>The Proof of Concept will demonstrate the core principle of this platform: deployment is a GitHub event, not a manual console activity. A developer pushes code, and everything else — building the image, provisioning infrastructure, deploying the service, and publishing the evidence — is handled entirely by GitHub Actions.</a:t>
             </a:r>
           </a:p>
           <a:p>
             <a:pPr algn="l"/>
             <a:r>
-              <a:rPr sz="750" b="0">
+              <a:rPr sz="300" b="0" i="0">
                 <a:solidFill>
                   <a:srgbClr val="1A1A2E"/>
                 </a:solidFill>
@@ -4706,84 +4484,29 @@
           <a:p>
             <a:pPr algn="l"/>
             <a:r>
-              <a:rPr sz="750" b="1">
+              <a:rPr sz="800" b="1" i="0">
                 <a:solidFill>
                   <a:srgbClr val="1A1A2E"/>
                 </a:solidFill>
               </a:rPr>
-              <a:t>What we will demonstrate</a:t>
+              <a:t>What the demonstration will show:</a:t>
             </a:r>
           </a:p>
           <a:p>
             <a:pPr algn="l"/>
             <a:r>
-              <a:rPr sz="750" b="0">
+              <a:rPr sz="800" b="0" i="0">
                 <a:solidFill>
                   <a:srgbClr val="1A1A2E"/>
                 </a:solidFill>
               </a:rPr>
-              <a:t>1. Developer pushes code (or triggers workflow_dispatch) – no AWS Console</a:t>
+              <a:t>GitHub Actions will build the Apache Tomcat container image, push it to Amazon ECR with an immutable commit SHA tag, apply the Terraform ECS Fargate stack, update the running service, and execute a smoke test against the Application Load Balancer endpoint — all without the developer logging in to the AWS Console.</a:t>
             </a:r>
           </a:p>
           <a:p>
             <a:pPr algn="l"/>
             <a:r>
-              <a:rPr sz="750" b="0">
-                <a:solidFill>
-                  <a:srgbClr val="1A1A2E"/>
-                </a:solidFill>
-              </a:rPr>
-              <a:t>2. GitHub Actions builds Tomcat image from sample-code/tomcat</a:t>
-            </a:r>
-          </a:p>
-          <a:p>
-            <a:pPr algn="l"/>
-            <a:r>
-              <a:rPr sz="750" b="0">
-                <a:solidFill>
-                  <a:srgbClr val="1A1A2E"/>
-                </a:solidFill>
-              </a:rPr>
-              <a:t>3. Image pushed to ECR with immutable SHA tag</a:t>
-            </a:r>
-          </a:p>
-          <a:p>
-            <a:pPr algn="l"/>
-            <a:r>
-              <a:rPr sz="750" b="0">
-                <a:solidFill>
-                  <a:srgbClr val="1A1A2E"/>
-                </a:solidFill>
-              </a:rPr>
-              <a:t>4. Terraform applies ECS Fargate stack (cluster / service / ALB)</a:t>
-            </a:r>
-          </a:p>
-          <a:p>
-            <a:pPr algn="l"/>
-            <a:r>
-              <a:rPr sz="750" b="0">
-                <a:solidFill>
-                  <a:srgbClr val="1A1A2E"/>
-                </a:solidFill>
-              </a:rPr>
-              <a:t>5. ECS service updated; smoke test validates ALB endpoint</a:t>
-            </a:r>
-          </a:p>
-          <a:p>
-            <a:pPr algn="l"/>
-            <a:r>
-              <a:rPr sz="750" b="0">
-                <a:solidFill>
-                  <a:srgbClr val="1A1A2E"/>
-                </a:solidFill>
-              </a:rPr>
-              <a:t>6. Deployment summary published: image, SHA, endpoint, workflow run</a:t>
-            </a:r>
-          </a:p>
-          <a:p>
-            <a:pPr algn="l"/>
-            <a:r>
-              <a:rPr sz="750" b="0">
+              <a:rPr sz="300" b="0" i="0">
                 <a:solidFill>
                   <a:srgbClr val="1A1A2E"/>
                 </a:solidFill>
@@ -4794,76 +4517,32 @@
           <a:p>
             <a:pPr algn="l"/>
             <a:r>
-              <a:rPr sz="750" b="1">
+              <a:rPr sz="800" b="0" i="0">
                 <a:solidFill>
                   <a:srgbClr val="1A1A2E"/>
                 </a:solidFill>
               </a:rPr>
-              <a:t>Success Criteria</a:t>
-            </a:r>
-          </a:p>
-          <a:p>
-            <a:pPr algn="l"/>
-            <a:r>
-              <a:rPr sz="750" b="0">
-                <a:solidFill>
-                  <a:srgbClr val="1A1A2E"/>
-                </a:solidFill>
-              </a:rPr>
-              <a:t>✅ No developer AWS console access needed  ✅ ECS tasks healthy</a:t>
-            </a:r>
-          </a:p>
-          <a:p>
-            <a:pPr algn="l"/>
-            <a:r>
-              <a:rPr sz="750" b="0">
-                <a:solidFill>
-                  <a:srgbClr val="1A1A2E"/>
-                </a:solidFill>
-              </a:rPr>
-              <a:t>✅ ALB returns Tomcat Hello World  ✅ Evidence tied to commit SHA</a:t>
-            </a:r>
-          </a:p>
-          <a:p>
-            <a:pPr algn="l"/>
-            <a:r>
-              <a:rPr sz="750" b="0">
-                <a:solidFill>
-                  <a:srgbClr val="1A1A2E"/>
-                </a:solidFill>
-              </a:rPr>
-              <a:t/>
-            </a:r>
-          </a:p>
-          <a:p>
-            <a:pPr algn="l"/>
-            <a:r>
-              <a:rPr sz="750" b="0">
-                <a:solidFill>
-                  <a:srgbClr val="1A1A2E"/>
-                </a:solidFill>
-              </a:rPr>
-              <a:t>Next hardening: Blue/green deploy · HTTPS · WAF · Private subnets · prod approvals</a:t>
-            </a:r>
-          </a:p>
-        </p:txBody>
-      </p:sp>
-      <p:sp>
-        <p:nvSpPr>
-          <p:cNvPr id="30" name="Rectangle 29"/>
+              <a:t>The POC is considered successful when the ALB returns the Tomcat application page, the ECS tasks are healthy, and the deployment record is fully traceable back to the originating commit SHA and workflow run.</a:t>
+            </a:r>
+          </a:p>
+        </p:txBody>
+      </p:sp>
+      <p:sp>
+        <p:nvSpPr>
+          <p:cNvPr id="29" name="Rectangle 28"/>
           <p:cNvSpPr/>
           <p:nvPr/>
         </p:nvSpPr>
         <p:spPr>
           <a:xfrm>
-            <a:off x="0" y="6601968"/>
-            <a:ext cx="12188952" cy="256032"/>
+            <a:off x="0" y="6620256"/>
+            <a:ext cx="12188952" cy="237744"/>
           </a:xfrm>
           <a:prstGeom prst="rect">
             <a:avLst/>
           </a:prstGeom>
           <a:solidFill>
-            <a:srgbClr val="0D1B3E"/>
+            <a:srgbClr val="0C1C43"/>
           </a:solidFill>
           <a:ln>
             <a:noFill/>
@@ -4893,14 +4572,14 @@
       </p:sp>
       <p:sp>
         <p:nvSpPr>
-          <p:cNvPr id="31" name="TextBox 30"/>
+          <p:cNvPr id="30" name="TextBox 29"/>
           <p:cNvSpPr txBox="1"/>
           <p:nvPr/>
         </p:nvSpPr>
         <p:spPr>
           <a:xfrm>
-            <a:off x="182880" y="6611112"/>
-            <a:ext cx="5943600" cy="219456"/>
+            <a:off x="201168" y="6624828"/>
+            <a:ext cx="6400800" cy="201168"/>
           </a:xfrm>
           <a:prstGeom prst="rect">
             <a:avLst/>
@@ -4920,21 +4599,21 @@
                   <a:srgbClr val="80A0D0"/>
                 </a:solidFill>
               </a:rPr>
-              <a:t>CONFIDENTIAL  |  Platform Engineering  |  App as Code – Phase 1 Baseline v1.0</a:t>
-            </a:r>
-          </a:p>
-        </p:txBody>
-      </p:sp>
-      <p:sp>
-        <p:nvSpPr>
-          <p:cNvPr id="32" name="TextBox 31"/>
+              <a:t>Confidential  |  Platform Engineering  |  App as Code — Phase 1 Baseline v1.0</a:t>
+            </a:r>
+          </a:p>
+        </p:txBody>
+      </p:sp>
+      <p:sp>
+        <p:nvSpPr>
+          <p:cNvPr id="31" name="TextBox 30"/>
           <p:cNvSpPr txBox="1"/>
           <p:nvPr/>
         </p:nvSpPr>
         <p:spPr>
           <a:xfrm>
-            <a:off x="6400800" y="6611112"/>
-            <a:ext cx="5605272" cy="219456"/>
+            <a:off x="6400800" y="6624828"/>
+            <a:ext cx="5577840" cy="201168"/>
           </a:xfrm>
           <a:prstGeom prst="rect">
             <a:avLst/>

</xml_diff>